<commit_message>
Promote the contributor table into results/tables/
A full `make results` wrote tables 1, 3 and 4 to results/tables/ and left
table 2 behind in results/representative/, so the directory the README
points at looked like it was missing a table and RESULTS.md numbered its
sections 1, 3, 4.

Table 2 needs findings joined to the answer key, which only the
representative cell has, so it is built there — but it now gets promoted
alongside the sweep-wide tables and placed in RESULTS.md in order, with a
line saying which cell it came from and why it cannot be averaged across
the sweep (contributor C2 in one cell is not the same actor as C2 in the
next).

A test reads the source and fails if either half of that is dropped.

Co-Authored-By: Claude Opus 5 <noreply@anthropic.com>
</commit_message>
<xml_diff>
--- a/ppt_build/SIH2026_PS26228_cvassure.pptx
+++ b/ppt_build/SIH2026_PS26228_cvassure.pptx
@@ -7722,7 +7722,7 @@
                 </a:solidFill>
                 <a:latin typeface="Cambria"/>
               </a:rPr>
-              <a:t>301</a:t>
+              <a:t>302</a:t>
             </a:r>
           </a:p>
         </p:txBody>
@@ -11902,7 +11902,7 @@
                 </a:solidFill>
                 <a:latin typeface="Calibri"/>
               </a:rPr>
-              <a:t> Not a concept — 301 tests, 270 swept cells, four results tables.</a:t>
+              <a:t> Not a concept — 302 tests, 270 swept cells, four results tables.</a:t>
             </a:r>
           </a:p>
           <a:p>
@@ -16551,7 +16551,7 @@
                 </a:solidFill>
                 <a:latin typeface="Calibri"/>
               </a:rPr>
-              <a:t>  runs 301 tests plus the assertion that nothing touched the network.</a:t>
+              <a:t>  runs 302 tests plus the assertion that nothing touched the network.</a:t>
             </a:r>
           </a:p>
           <a:p>

</xml_diff>

<commit_message>
Never report an unchecked model as verified unchanged
With no enrolment record, fingerprint and weight_digest both go unavailable.
The headline then fell through to "Model: verified unchanged." and a green
light — on a model that had in fact been swapped. For a tool whose entire
claim is that it says what it cannot establish, this was the worst bug in
the codebase.

Only fingerprint and weight_digest can establish that a file is the one we
were given; weight_stats and spectral_signature are worth running but cannot.
When neither identity check ran, the verdict now names what was missing and
says a swapped model would not have been caught, and the light goes amber.

Also fixes slide 5 of the deck, which drew its banner from one run, its bar
chart from another and its caption from a third. All three now come from a
single audit of a pipeline compromised in all three places, which the README
gives as a copy-pasteable command.

Co-Authored-By: Claude Opus 5 <noreply@anthropic.com>
</commit_message>
<xml_diff>
--- a/ppt_build/SIH2026_PS26228_cvassure.pptx
+++ b/ppt_build/SIH2026_PS26228_cvassure.pptx
@@ -13889,7 +13889,7 @@
         <p:spPr>
           <a:xfrm>
             <a:off x="329184" y="1371600"/>
-            <a:ext cx="5897880" cy="858695"/>
+            <a:ext cx="5577840" cy="906887"/>
           </a:xfrm>
           <a:prstGeom prst="rect">
             <a:avLst/>
@@ -13904,7 +13904,7 @@
         </p:nvSpPr>
         <p:spPr>
           <a:xfrm>
-            <a:off x="329184" y="2304288"/>
+            <a:off x="329184" y="2313432"/>
             <a:ext cx="5897880" cy="256032"/>
           </a:xfrm>
           <a:prstGeom prst="rect">
@@ -13933,7 +13933,7 @@
                 </a:solidFill>
                 <a:latin typeface="Calibri"/>
               </a:rPr>
-              <a:t>Real output. One offline HTML file — no dashboard to host, nothing to install on the analyst's machine.</a:t>
+              <a:t>Real output from one command on one contaminated intake. Every figure on this slide is that same run.</a:t>
             </a:r>
           </a:p>
         </p:txBody>
@@ -13999,7 +13999,7 @@
         <p:spPr>
           <a:xfrm>
             <a:off x="448056" y="2706624"/>
-            <a:ext cx="2737001" cy="1965960"/>
+            <a:ext cx="2716197" cy="1965960"/>
           </a:xfrm>
           <a:prstGeom prst="rect">
             <a:avLst/>
@@ -14109,7 +14109,7 @@
         <p:spPr>
           <a:xfrm>
             <a:off x="3520440" y="2706624"/>
-            <a:ext cx="2961482" cy="1965960"/>
+            <a:ext cx="3016814" cy="1965960"/>
           </a:xfrm>
           <a:prstGeom prst="rect">
             <a:avLst/>
@@ -14153,7 +14153,7 @@
                 </a:solidFill>
                 <a:latin typeface="Calibri"/>
               </a:rPr>
-              <a:t>What we did, against what was true.</a:t>
+              <a:t>21 poisoned images: 18 caught, 3 missed.</a:t>
             </a:r>
           </a:p>
         </p:txBody>
@@ -14276,7 +14276,7 @@
                 </a:solidFill>
                 <a:latin typeface="Calibri"/>
               </a:rPr>
-              <a:t>one line — quarantine Contributor C3, whose true poison rate was 51% and whom we scored 45% with a 36–54% interval.</a:t>
+              <a:t>one line — quarantine Contributor C3, whose true poison rate was 51% and whom we scored 45% with a 36–54% interval. All 3 bad actors caught; 1 clean source over-flagged for review, never quarantined.</a:t>
             </a:r>
           </a:p>
         </p:txBody>

</xml_diff>